<commit_message>
Videoaula: ReLU, pooling e filtros da 2ª convolução explicados sem jargão
Tira as comparações com regressão linear e logística, que a turma pode não
conhecer.

Co-Authored-By: Claude Opus 5.5 <noreply@anthropic.com>
Claude-Session: https://claude.ai/code/session_01A3qCAYujkSgL8eDkrfkPwq
</commit_message>
<xml_diff>
--- a/code/cnn-pneumonia-r/slides/videoaula_cnn_r.pptx
+++ b/code/cnn-pneumonia-r/slides/videoaula_cnn_r.pptx
@@ -706,7 +706,7 @@
           <a:p>
             <a:r>
               <a:rPr lang="en-US" dirty="0"/>
-              <a:t>[9:45–10:45] Junte as peças e siga um raio-X. Entra 1 imagem de 28 por 28. A primeira convolução gera 16 mapas; o pooling os reduz para 14 por 14. A segunda convolução gera 32 mapas, reduzidos para 7 por 7. Aí começa a parte 2: achatar, camada densa e saída. Explique cada número: 16 e 32 são escolhas; 14 e 7 vêm do pooling; 1.568 é 32 vezes 7 vezes 7.</a:t>
+              <a:t>[9:45–10:45] Junte as peças e siga um raio-X. Entra 1 imagem de 28 por 28. A primeira convolução gera 16 mapas; o pooling os reduz para 14 por 14. A segunda convolução gera 32 mapas, reduzidos para 7 por 7. Aí começa a parte 2: achatar, camada densa e saída. Explique cada número: 14 e 7 vêm do pooling; 1.568 é 32 vezes 7 vezes 7. E por que a 2ª convolução tem mais filtros: ela combina os padrões simples da 1ª em padrões mais complexos, e há muito mais combinações do que padrões simples.</a:t>
             </a:r>
             <a:endParaRPr lang="en-US" dirty="0"/>
           </a:p>
@@ -882,7 +882,7 @@
           <a:p>
             <a:r>
               <a:rPr lang="en-US" dirty="0"/>
-              <a:t>[11:45–12:45] A rede termina com dois números, as pontuações — uma para normal, outra para pneumonia. Sozinhas elas não são probabilidades. O softmax as converte: eleva e a cada pontuação e divide pelo total; aqui dá 13% e 87%. Quem conhece regressão logística: com duas classes é a mesma função logística. A resposta final é a classe mais provável.</a:t>
+              <a:t>[11:45–12:45] A rede termina com dois números, as pontuações — uma para normal, outra para pneumonia. Sozinhas elas não são probabilidades. O softmax as converte: eleva e a cada pontuação e divide pelo total; aqui dá 13% e 87%. A resposta final é a classe mais provável.</a:t>
             </a:r>
             <a:endParaRPr lang="en-US" dirty="0"/>
           </a:p>
@@ -970,7 +970,7 @@
           <a:p>
             <a:r>
               <a:rPr lang="en-US" dirty="0"/>
-              <a:t>[12:45–13:45] Para aprender, a rede precisa medir o erro. Na classificação, a medida é a entropia cruzada: o menos logaritmo da probabilidade que a rede deu à classe correta. Leia a tabela: 90% na classe certa, perda baixa; 10%, perda alta. Faça a ponte com a regressão linear, onde o erro é medido pela soma dos quadrados.</a:t>
+              <a:t>[12:45–13:45] Para aprender, a rede precisa medir o erro. Na classificação, a medida é a entropia cruzada: o menos logaritmo da probabilidade que a rede deu à classe correta. Leia a tabela: 90% na classe certa, perda baixa; 10%, perda alta.</a:t>
             </a:r>
             <a:endParaRPr lang="en-US" dirty="0"/>
           </a:p>
@@ -2466,7 +2466,7 @@
           <a:p>
             <a:r>
               <a:rPr lang="en-US" dirty="0"/>
-              <a:t>[1:00–2:00] Defina a tarefa: entra uma imagem, sai a probabilidade de pneumonia. Ligue com o que a turma conhece: é classificação, como a regressão logística, só que a entrada é uma imagem. O modelo aprende com exemplos já diagnosticados.</a:t>
+              <a:t>[1:00–2:00] Defina a tarefa: entra uma imagem, sai a probabilidade de pneumonia. É um problema de classificação: duas classes possíveis. O modelo aprende com exemplos já diagnosticados.</a:t>
             </a:r>
             <a:endParaRPr lang="en-US" dirty="0"/>
           </a:p>
@@ -2554,7 +2554,7 @@
           <a:p>
             <a:r>
               <a:rPr lang="en-US" dirty="0"/>
-              <a:t>[2:00–3:30] Antes da CNN, a peça básica. Um neurônio é uma soma ponderada: pega as entradas, multiplica cada uma por um peso, soma, e soma um intercepto. Quem fez regressão linear já conhece essa fórmula. A rede neural junta muitos desses em camadas. Os pesos começam sorteados e são ajustados com os dados — como estimar os coeficientes de uma regressão. Camada densa é o nome da camada em que cada neurônio olha todas as entradas.</a:t>
+              <a:t>[2:00–3:30] Antes da CNN, a peça básica. Um neurônio é uma soma ponderada: pega as entradas, multiplica cada uma por um peso, soma, e soma mais um número fixo. Faça a conta do exemplo. A rede neural junta muitos desses em camadas. Os pesos começam sorteados e são ajustados no treino, a partir dos exemplos. Camada densa é o nome da camada em que cada neurônio olha todas as entradas.</a:t>
             </a:r>
             <a:endParaRPr lang="en-US" dirty="0"/>
           </a:p>
@@ -2994,7 +2994,7 @@
           <a:p>
             <a:r>
               <a:rPr lang="en-US" dirty="0"/>
-              <a:t>[7:45–8:45] Mostre o antes e depois: o azul some, fica só o laranja. Dois motivos para a ReLU. Primeiro, ela limpa o mapa: fica só onde o filtro achou o padrão. Segundo, e mais importante: se a rede só fizesse somas ponderadas, uma depois da outra, o resultado final ainda seria uma soma ponderada, uma regressão linear. A ReLU quebra essa linearidade e deixa a rede aprender relações mais complicadas.</a:t>
+              <a:t>[7:45–8:45] Mostre o antes e depois: o azul some, fica só o laranja. Dois motivos. Primeiro, ela limpa o mapa: fica só onde o filtro achou o padrão. Segundo: sem ela, empilhar camadas não adiantaria, porque multiplicar e somar várias vezes seguidas dá o mesmo que multiplicar e somar uma vez só — use o exemplo de dobrar e triplicar, que dá multiplicar por 6. O corte no zero quebra isso. Por fim, mostre onde ela fica: sempre logo depois da convolução.</a:t>
             </a:r>
             <a:endParaRPr lang="en-US" dirty="0"/>
           </a:p>
@@ -5233,7 +5233,7 @@
                 <a:ea typeface="Calibri" pitchFamily="34" charset="-122"/>
                 <a:cs typeface="Calibri" pitchFamily="34" charset="-120"/>
               </a:rPr>
-              <a:t>menos contas nas camadas seguintes, e um padrão deslocado um pixel para o lado dá quase o mesmo resultado.</a:t>
+              <a:t>1) com o mapa 4 vezes menor, as camadas seguintes têm menos contas a fazer. 2) importa saber se o padrão apareceu naquela região, não em qual pixel exato: se uma borda está num pixel ou no vizinho, dentro do mesmo bloco, o maior valor do bloco é o mesmo.</a:t>
             </a:r>
             <a:endParaRPr lang="en-US" sz="1600" dirty="0"/>
           </a:p>
@@ -6337,8 +6337,8 @@
         </p:nvSpPr>
         <p:spPr>
           <a:xfrm>
-            <a:off x="548640" y="3611880"/>
-            <a:ext cx="11094415" cy="2926080"/>
+            <a:off x="548640" y="3520440"/>
+            <a:ext cx="11094415" cy="3108960"/>
           </a:xfrm>
           <a:prstGeom prst="rect">
             <a:avLst/>
@@ -6357,7 +6357,7 @@
               <a:buNone/>
             </a:pPr>
             <a:r>
-              <a:rPr lang="en-US" sz="1600" b="1" dirty="0">
+              <a:rPr lang="en-US" sz="1500" b="1" dirty="0">
                 <a:solidFill>
                   <a:srgbClr val="0B0B0B"/>
                 </a:solidFill>
@@ -6374,7 +6374,7 @@
               <a:buNone/>
             </a:pPr>
             <a:r>
-              <a:rPr lang="en-US" sz="1600" dirty="0">
+              <a:rPr lang="en-US" sz="1500" dirty="0">
                 <a:solidFill>
                   <a:srgbClr val="0B0B0B"/>
                 </a:solidFill>
@@ -6384,7 +6384,7 @@
               </a:rPr>
               <a:t>cada um dos 16 filtros gera um mapa; cada mapa tem 14 linhas e 14 colunas.</a:t>
             </a:r>
-            <a:endParaRPr lang="en-US" sz="1600" dirty="0"/>
+            <a:endParaRPr lang="en-US" sz="1500" dirty="0"/>
           </a:p>
           <a:p>
             <a:pPr indent="0" marL="0">
@@ -6394,7 +6394,7 @@
               <a:buNone/>
             </a:pPr>
             <a:r>
-              <a:rPr lang="en-US" sz="1600" b="1" dirty="0">
+              <a:rPr lang="en-US" sz="1500" b="1" dirty="0">
                 <a:solidFill>
                   <a:srgbClr val="0B0B0B"/>
                 </a:solidFill>
@@ -6402,7 +6402,7 @@
                 <a:ea typeface="Calibri" pitchFamily="34" charset="-122"/>
                 <a:cs typeface="Calibri" pitchFamily="34" charset="-120"/>
               </a:rPr>
-              <a:t>De onde vêm 16 e 32: </a:t>
+              <a:t>28 → 14 → 7: </a:t>
             </a:r>
             <a:pPr indent="0" marL="0">
               <a:spcAft>
@@ -6411,7 +6411,7 @@
               <a:buNone/>
             </a:pPr>
             <a:r>
-              <a:rPr lang="en-US" sz="1600" dirty="0">
+              <a:rPr lang="en-US" sz="1500" dirty="0">
                 <a:solidFill>
                   <a:srgbClr val="0B0B0B"/>
                 </a:solidFill>
@@ -6419,9 +6419,9 @@
                 <a:ea typeface="Calibri" pitchFamily="34" charset="-122"/>
                 <a:cs typeface="Calibri" pitchFamily="34" charset="-120"/>
               </a:rPr>
-              <a:t>é quem monta a rede que escolhe quantos filtros cada convolução tem.</a:t>
-            </a:r>
-            <a:endParaRPr lang="en-US" sz="1600" dirty="0"/>
+              <a:t>cada pooling corta o tamanho pela metade.</a:t>
+            </a:r>
+            <a:endParaRPr lang="en-US" sz="1500" dirty="0"/>
           </a:p>
           <a:p>
             <a:pPr indent="0" marL="0">
@@ -6431,7 +6431,7 @@
               <a:buNone/>
             </a:pPr>
             <a:r>
-              <a:rPr lang="en-US" sz="1600" b="1" dirty="0">
+              <a:rPr lang="en-US" sz="1500" b="1" dirty="0">
                 <a:solidFill>
                   <a:srgbClr val="0B0B0B"/>
                 </a:solidFill>
@@ -6439,7 +6439,7 @@
                 <a:ea typeface="Calibri" pitchFamily="34" charset="-122"/>
                 <a:cs typeface="Calibri" pitchFamily="34" charset="-120"/>
               </a:rPr>
-              <a:t>28 → 14 → 7: </a:t>
+              <a:t>Por que 32 filtros na 2ª convolução e só 16 na 1ª? </a:t>
             </a:r>
             <a:pPr indent="0" marL="0">
               <a:spcAft>
@@ -6448,7 +6448,7 @@
               <a:buNone/>
             </a:pPr>
             <a:r>
-              <a:rPr lang="en-US" sz="1600" dirty="0">
+              <a:rPr lang="en-US" sz="1500" dirty="0">
                 <a:solidFill>
                   <a:srgbClr val="0B0B0B"/>
                 </a:solidFill>
@@ -6456,9 +6456,9 @@
                 <a:ea typeface="Calibri" pitchFamily="34" charset="-122"/>
                 <a:cs typeface="Calibri" pitchFamily="34" charset="-120"/>
               </a:rPr>
-              <a:t>cada pooling corta o tamanho pela metade.</a:t>
-            </a:r>
-            <a:endParaRPr lang="en-US" sz="1600" dirty="0"/>
+              <a:t>a 1ª procura padrões simples (bordas, contrastes), e há poucos tipos deles. Os filtros da 2ª olham os 16 mapas da 1ª ao mesmo tempo e combinam esses padrões simples em padrões mais complexos (formas, texturas). Há muito mais combinações possíveis, então vale ter mais filtros. E como o pooling encolheu os mapas, 32 mapas de 14 × 14 (6.272 números) ainda ocupam metade do espaço de 16 mapas de 28 × 28 (12.544). Os valores exatos, 16 e 32, são escolhas de quem monta a rede.</a:t>
+            </a:r>
+            <a:endParaRPr lang="en-US" sz="1500" dirty="0"/>
           </a:p>
           <a:p>
             <a:pPr indent="0" marL="0">
@@ -6468,7 +6468,7 @@
               <a:buNone/>
             </a:pPr>
             <a:r>
-              <a:rPr lang="en-US" sz="1600" b="1" dirty="0">
+              <a:rPr lang="en-US" sz="1500" b="1" dirty="0">
                 <a:solidFill>
                   <a:srgbClr val="0B0B0B"/>
                 </a:solidFill>
@@ -6476,7 +6476,7 @@
                 <a:ea typeface="Calibri" pitchFamily="34" charset="-122"/>
                 <a:cs typeface="Calibri" pitchFamily="34" charset="-120"/>
               </a:rPr>
-              <a:t>Do simples ao complexo: </a:t>
+              <a:t>1.568 = 32 × 7 × 7: </a:t>
             </a:r>
             <a:pPr indent="0" marL="0">
               <a:spcAft>
@@ -6485,7 +6485,7 @@
               <a:buNone/>
             </a:pPr>
             <a:r>
-              <a:rPr lang="en-US" sz="1600" dirty="0">
+              <a:rPr lang="en-US" sz="1500" dirty="0">
                 <a:solidFill>
                   <a:srgbClr val="0B0B0B"/>
                 </a:solidFill>
@@ -6493,46 +6493,9 @@
                 <a:ea typeface="Calibri" pitchFamily="34" charset="-122"/>
                 <a:cs typeface="Calibri" pitchFamily="34" charset="-120"/>
               </a:rPr>
-              <a:t>os filtros da 2ª convolução olham os 16 mapas da 1ª ao mesmo tempo. Assim, combinam padrões simples (bordas) em padrões mais complexos (formas, texturas).</a:t>
-            </a:r>
-            <a:endParaRPr lang="en-US" sz="1600" dirty="0"/>
-          </a:p>
-          <a:p>
-            <a:pPr indent="0" marL="0">
-              <a:spcAft>
-                <a:spcPts val="800"/>
-              </a:spcAft>
-              <a:buNone/>
-            </a:pPr>
-            <a:r>
-              <a:rPr lang="en-US" sz="1600" b="1" dirty="0">
-                <a:solidFill>
-                  <a:srgbClr val="0B0B0B"/>
-                </a:solidFill>
-                <a:latin typeface="Calibri" pitchFamily="34" charset="0"/>
-                <a:ea typeface="Calibri" pitchFamily="34" charset="-122"/>
-                <a:cs typeface="Calibri" pitchFamily="34" charset="-120"/>
-              </a:rPr>
-              <a:t>1.568 = 32 × 7 × 7: </a:t>
-            </a:r>
-            <a:pPr indent="0" marL="0">
-              <a:spcAft>
-                <a:spcPts val="800"/>
-              </a:spcAft>
-              <a:buNone/>
-            </a:pPr>
-            <a:r>
-              <a:rPr lang="en-US" sz="1600" dirty="0">
-                <a:solidFill>
-                  <a:srgbClr val="0B0B0B"/>
-                </a:solidFill>
-                <a:latin typeface="Calibri" pitchFamily="34" charset="0"/>
-                <a:ea typeface="Calibri" pitchFamily="34" charset="-122"/>
-                <a:cs typeface="Calibri" pitchFamily="34" charset="-120"/>
-              </a:rPr>
               <a:t>todos os números dos 32 mapas, postos em fila.</a:t>
             </a:r>
-            <a:endParaRPr lang="en-US" sz="1600" dirty="0"/>
+            <a:endParaRPr lang="en-US" sz="1500" dirty="0"/>
           </a:p>
         </p:txBody>
       </p:sp>
@@ -8926,43 +8889,6 @@
                 <a:cs typeface="Calibri" pitchFamily="34" charset="-120"/>
               </a:rPr>
               <a:t>transforma as pontuações em probabilidades que somam 100%.  p(pneumonia) = e^3,1 / (e^1,2 + e^3,1) = 0,87.</a:t>
-            </a:r>
-            <a:endParaRPr lang="en-US" sz="1700" dirty="0"/>
-          </a:p>
-          <a:p>
-            <a:pPr indent="0" marL="0">
-              <a:spcAft>
-                <a:spcPts val="1000"/>
-              </a:spcAft>
-              <a:buNone/>
-            </a:pPr>
-            <a:r>
-              <a:rPr lang="en-US" sz="1700" b="1" dirty="0">
-                <a:solidFill>
-                  <a:srgbClr val="0B0B0B"/>
-                </a:solidFill>
-                <a:latin typeface="Calibri" pitchFamily="34" charset="0"/>
-                <a:ea typeface="Calibri" pitchFamily="34" charset="-122"/>
-                <a:cs typeface="Calibri" pitchFamily="34" charset="-120"/>
-              </a:rPr>
-              <a:t>Com 2 classes, </a:t>
-            </a:r>
-            <a:pPr indent="0" marL="0">
-              <a:spcAft>
-                <a:spcPts val="1000"/>
-              </a:spcAft>
-              <a:buNone/>
-            </a:pPr>
-            <a:r>
-              <a:rPr lang="en-US" sz="1700" dirty="0">
-                <a:solidFill>
-                  <a:srgbClr val="0B0B0B"/>
-                </a:solidFill>
-                <a:latin typeface="Calibri" pitchFamily="34" charset="0"/>
-                <a:ea typeface="Calibri" pitchFamily="34" charset="-122"/>
-                <a:cs typeface="Calibri" pitchFamily="34" charset="-120"/>
-              </a:rPr>
-              <a:t>o softmax é a mesma função logística da regressão logística.</a:t>
             </a:r>
             <a:endParaRPr lang="en-US" sz="1700" dirty="0"/>
           </a:p>
@@ -10055,43 +9981,6 @@
                 <a:cs typeface="Calibri" pitchFamily="34" charset="-120"/>
               </a:rPr>
               <a:t>a perda é a média das perdas de cada imagem.</a:t>
-            </a:r>
-            <a:endParaRPr lang="en-US" sz="1600" dirty="0"/>
-          </a:p>
-          <a:p>
-            <a:pPr indent="0" marL="0">
-              <a:spcAft>
-                <a:spcPts val="600"/>
-              </a:spcAft>
-              <a:buNone/>
-            </a:pPr>
-            <a:r>
-              <a:rPr lang="en-US" sz="1600" b="1" dirty="0">
-                <a:solidFill>
-                  <a:srgbClr val="0B0B0B"/>
-                </a:solidFill>
-                <a:latin typeface="Calibri" pitchFamily="34" charset="0"/>
-                <a:ea typeface="Calibri" pitchFamily="34" charset="-122"/>
-                <a:cs typeface="Calibri" pitchFamily="34" charset="-120"/>
-              </a:rPr>
-              <a:t>Parente conhecido: </a:t>
-            </a:r>
-            <a:pPr indent="0" marL="0">
-              <a:spcAft>
-                <a:spcPts val="600"/>
-              </a:spcAft>
-              <a:buNone/>
-            </a:pPr>
-            <a:r>
-              <a:rPr lang="en-US" sz="1600" dirty="0">
-                <a:solidFill>
-                  <a:srgbClr val="0B0B0B"/>
-                </a:solidFill>
-                <a:latin typeface="Calibri" pitchFamily="34" charset="0"/>
-                <a:ea typeface="Calibri" pitchFamily="34" charset="-122"/>
-                <a:cs typeface="Calibri" pitchFamily="34" charset="-120"/>
-              </a:rPr>
-              <a:t>é o mesmo critério da regressão logística. Na regressão linear, o papel é da soma dos quadrados dos erros.</a:t>
             </a:r>
             <a:endParaRPr lang="en-US" sz="1600" dirty="0"/>
           </a:p>
@@ -22694,7 +22583,7 @@
                 <a:ea typeface="Calibri" pitchFamily="34" charset="-122"/>
                 <a:cs typeface="Calibri" pitchFamily="34" charset="-120"/>
               </a:rPr>
-              <a:t>cada observação recebe uma de duas classes, normal ou pneumonia — como na regressão logística. A diferença é que aqui cada observação é uma imagem, não uma linha de tabela.</a:t>
+              <a:t>o modelo coloca cada raio-X em uma de duas classes: normal ou pneumonia.</a:t>
             </a:r>
             <a:endParaRPr lang="en-US" sz="1700" dirty="0"/>
           </a:p>
@@ -23465,7 +23354,7 @@
                 <a:ea typeface="Calibri" pitchFamily="34" charset="-122"/>
                 <a:cs typeface="Calibri" pitchFamily="34" charset="-120"/>
               </a:rPr>
-              <a:t>multiplica cada entrada por um peso, soma tudo e soma um intercepto b. É a fórmula da regressão linear.</a:t>
+              <a:t>multiplica cada entrada por um peso e soma tudo (isso se chama soma ponderada), mais um número fixo, b. Ex.: entradas 2, 1, 3 e pesos 0,5, −1, 2 → 1 − 1 + 6 = 6, mais b.</a:t>
             </a:r>
             <a:endParaRPr lang="en-US" sz="1700" dirty="0"/>
           </a:p>
@@ -23502,7 +23391,7 @@
                 <a:ea typeface="Calibri" pitchFamily="34" charset="-122"/>
                 <a:cs typeface="Calibri" pitchFamily="34" charset="-120"/>
               </a:rPr>
-              <a:t>não são escolhidos à mão. São aprendidos a partir dos dados, como os coeficientes de uma regressão.</a:t>
+              <a:t>não são escolhidos à mão: começam sorteados e são ajustados no treino, a partir dos exemplos.</a:t>
             </a:r>
             <a:endParaRPr lang="en-US" sz="1700" dirty="0"/>
           </a:p>
@@ -29067,7 +28956,7 @@
                 <a:ea typeface="Calibri" pitchFamily="34" charset="-122"/>
                 <a:cs typeface="Calibri" pitchFamily="34" charset="-120"/>
               </a:rPr>
-              <a:t>É como numa regressão: </a:t>
+              <a:t>Um filtro é só um conjunto de 9 pesos, </a:t>
             </a:r>
             <a:pPr indent="0" marL="0">
               <a:spcAft>
@@ -29084,7 +28973,7 @@
                 <a:ea typeface="Calibri" pitchFamily="34" charset="-122"/>
                 <a:cs typeface="Calibri" pitchFamily="34" charset="-120"/>
               </a:rPr>
-              <a:t>os coeficientes são estimados a partir dos dados.</a:t>
+              <a:t>iguais aos pesos do neurônio do começo da aula — por isso é aprendido do mesmo jeito.</a:t>
             </a:r>
             <a:endParaRPr lang="en-US" sz="1600" dirty="0"/>
           </a:p>
@@ -29923,8 +29812,8 @@
         </p:nvSpPr>
         <p:spPr>
           <a:xfrm>
-            <a:off x="6766560" y="1371600"/>
-            <a:ext cx="4873752" cy="5120640"/>
+            <a:off x="6766560" y="1280160"/>
+            <a:ext cx="4873752" cy="5303520"/>
           </a:xfrm>
           <a:prstGeom prst="rect">
             <a:avLst/>
@@ -29938,12 +29827,12 @@
           <a:p>
             <a:pPr indent="0" marL="0">
               <a:spcAft>
-                <a:spcPts val="1200"/>
+                <a:spcPts val="1000"/>
               </a:spcAft>
               <a:buNone/>
             </a:pPr>
             <a:r>
-              <a:rPr lang="en-US" sz="1600" b="1" dirty="0">
+              <a:rPr lang="en-US" sz="1500" b="1" dirty="0">
                 <a:solidFill>
                   <a:srgbClr val="0B0B0B"/>
                 </a:solidFill>
@@ -29955,12 +29844,12 @@
             </a:r>
             <a:pPr indent="0" marL="0">
               <a:spcAft>
-                <a:spcPts val="1200"/>
+                <a:spcPts val="1000"/>
               </a:spcAft>
               <a:buNone/>
             </a:pPr>
             <a:r>
-              <a:rPr lang="en-US" sz="1600" dirty="0">
+              <a:rPr lang="en-US" sz="1500" dirty="0">
                 <a:solidFill>
                   <a:srgbClr val="0B0B0B"/>
                 </a:solidFill>
@@ -29968,19 +29857,19 @@
                 <a:ea typeface="Calibri" pitchFamily="34" charset="-122"/>
                 <a:cs typeface="Calibri" pitchFamily="34" charset="-120"/>
               </a:rPr>
-              <a:t>valores negativos viram zero; valores positivos passam sem mudança.</a:t>
-            </a:r>
-            <a:endParaRPr lang="en-US" sz="1600" dirty="0"/>
+              <a:t>todo número negativo do mapa vira 0; os positivos continuam iguais (veja os números embaixo).</a:t>
+            </a:r>
+            <a:endParaRPr lang="en-US" sz="1500" dirty="0"/>
           </a:p>
           <a:p>
             <a:pPr indent="0" marL="0">
               <a:spcAft>
-                <a:spcPts val="1200"/>
+                <a:spcPts val="1000"/>
               </a:spcAft>
               <a:buNone/>
             </a:pPr>
             <a:r>
-              <a:rPr lang="en-US" sz="1600" b="1" dirty="0">
+              <a:rPr lang="en-US" sz="1500" b="1" dirty="0">
                 <a:solidFill>
                   <a:srgbClr val="0B0B0B"/>
                 </a:solidFill>
@@ -29988,16 +29877,16 @@
                 <a:ea typeface="Calibri" pitchFamily="34" charset="-122"/>
                 <a:cs typeface="Calibri" pitchFamily="34" charset="-120"/>
               </a:rPr>
-              <a:t>Por que, 1: </a:t>
+              <a:t>Motivo 1, limpar o mapa: </a:t>
             </a:r>
             <a:pPr indent="0" marL="0">
               <a:spcAft>
-                <a:spcPts val="1200"/>
+                <a:spcPts val="1000"/>
               </a:spcAft>
               <a:buNone/>
             </a:pPr>
             <a:r>
-              <a:rPr lang="en-US" sz="1600" dirty="0">
+              <a:rPr lang="en-US" sz="1500" dirty="0">
                 <a:solidFill>
                   <a:srgbClr val="0B0B0B"/>
                 </a:solidFill>
@@ -30005,19 +29894,19 @@
                 <a:ea typeface="Calibri" pitchFamily="34" charset="-122"/>
                 <a:cs typeface="Calibri" pitchFamily="34" charset="-120"/>
               </a:rPr>
-              <a:t>no mapa, valor negativo quer dizer que o padrão do filtro não está ali. Zerando, sobra no mapa só onde o padrão foi encontrado (o laranja).</a:t>
-            </a:r>
-            <a:endParaRPr lang="en-US" sz="1600" dirty="0"/>
+              <a:t>no mapa, número positivo alto quer dizer “o padrão do filtro está aqui”; número negativo quer dizer “aqui há o contrário do padrão”. A próxima camada só precisa saber onde o padrão está. A ReLU apaga o resto: o azul some e fica só o laranja.</a:t>
+            </a:r>
+            <a:endParaRPr lang="en-US" sz="1500" dirty="0"/>
           </a:p>
           <a:p>
             <a:pPr indent="0" marL="0">
               <a:spcAft>
-                <a:spcPts val="1200"/>
+                <a:spcPts val="1000"/>
               </a:spcAft>
               <a:buNone/>
             </a:pPr>
             <a:r>
-              <a:rPr lang="en-US" sz="1600" b="1" dirty="0">
+              <a:rPr lang="en-US" sz="1500" b="1" dirty="0">
                 <a:solidFill>
                   <a:srgbClr val="0B0B0B"/>
                 </a:solidFill>
@@ -30025,16 +29914,16 @@
                 <a:ea typeface="Calibri" pitchFamily="34" charset="-122"/>
                 <a:cs typeface="Calibri" pitchFamily="34" charset="-120"/>
               </a:rPr>
-              <a:t>Por que, 2: </a:t>
+              <a:t>Motivo 2, fazer cada camada valer a pena: </a:t>
             </a:r>
             <a:pPr indent="0" marL="0">
               <a:spcAft>
-                <a:spcPts val="1200"/>
+                <a:spcPts val="1000"/>
               </a:spcAft>
               <a:buNone/>
             </a:pPr>
             <a:r>
-              <a:rPr lang="en-US" sz="1600" dirty="0">
+              <a:rPr lang="en-US" sz="1500" dirty="0">
                 <a:solidFill>
                   <a:srgbClr val="0B0B0B"/>
                 </a:solidFill>
@@ -30042,19 +29931,19 @@
                 <a:ea typeface="Calibri" pitchFamily="34" charset="-122"/>
                 <a:cs typeface="Calibri" pitchFamily="34" charset="-120"/>
               </a:rPr>
-              <a:t>somas ponderadas empilhadas continuam sendo uma soma ponderada — sem a ReLU, a rede inteira seria uma grande regressão linear. A ReLU dobra essa reta e permite aprender relações complexas.</a:t>
-            </a:r>
-            <a:endParaRPr lang="en-US" sz="1600" dirty="0"/>
+              <a:t>sem a ReLU, cada camada só multiplica e soma, e várias contas de multiplicar e somar seguidas se resumem a uma só (dobrar e depois triplicar é o mesmo que multiplicar por 6). Dez camadas fariam o mesmo que uma. O corte no zero entre elas impede esse resumo, e cada camada consegue aprender algo novo.</a:t>
+            </a:r>
+            <a:endParaRPr lang="en-US" sz="1500" dirty="0"/>
           </a:p>
           <a:p>
             <a:pPr indent="0" marL="0">
               <a:spcAft>
-                <a:spcPts val="1200"/>
+                <a:spcPts val="1000"/>
               </a:spcAft>
               <a:buNone/>
             </a:pPr>
             <a:r>
-              <a:rPr lang="en-US" sz="1600" b="1" dirty="0">
+              <a:rPr lang="en-US" sz="1500" b="1" dirty="0">
                 <a:solidFill>
                   <a:srgbClr val="0B0B0B"/>
                 </a:solidFill>
@@ -30062,16 +29951,16 @@
                 <a:ea typeface="Calibri" pitchFamily="34" charset="-122"/>
                 <a:cs typeface="Calibri" pitchFamily="34" charset="-120"/>
               </a:rPr>
-              <a:t>Onde: </a:t>
+              <a:t>Onde ela fica: </a:t>
             </a:r>
             <a:pPr indent="0" marL="0">
               <a:spcAft>
-                <a:spcPts val="1200"/>
+                <a:spcPts val="1000"/>
               </a:spcAft>
               <a:buNone/>
             </a:pPr>
             <a:r>
-              <a:rPr lang="en-US" sz="1600" dirty="0">
+              <a:rPr lang="en-US" sz="1500" dirty="0">
                 <a:solidFill>
                   <a:srgbClr val="0B0B0B"/>
                 </a:solidFill>
@@ -30079,9 +29968,9 @@
                 <a:ea typeface="Calibri" pitchFamily="34" charset="-122"/>
                 <a:cs typeface="Calibri" pitchFamily="34" charset="-120"/>
               </a:rPr>
-              <a:t>depois de cada convolução e depois da camada densa.</a:t>
-            </a:r>
-            <a:endParaRPr lang="en-US" sz="1600" dirty="0"/>
+              <a:t>logo depois de cada convolução, antes do pooling (convolução → ReLU → pooling). Também aparece depois da camada densa, que vem mais adiante.</a:t>
+            </a:r>
+            <a:endParaRPr lang="en-US" sz="1500" dirty="0"/>
           </a:p>
         </p:txBody>
       </p:sp>

</xml_diff>